<commit_message>
Correct slide 4: separate the structural check from the actual finding
READ == T0 to four decimals is forced by the causal mask once the relevant image
precedes the distractor — it cannot see it, so readout is the only surviving
channel. Presenting that as a discovery would not survive a reviewer. Reframed as
an implementation-correctness check.

The real result is the other box: cutting image-to-image attention costs 0.29-0.42
AUC. A distractor contextualised by the relevant image is less harmful than an
isolated one, which is not what the design hypothesis predicted.

Also queues the swapped-order run, where the relevant image sits second and can
see the distractor, so a representation-contamination path genuinely exists. That
turns 'readout only' from a tautology into a claim with a stated boundary.

Co-Authored-By: Claude Fable 5 <noreply@anthropic.com>
</commit_message>
<xml_diff>
--- a/meeting/_generated/deck_v5.pptx
+++ b/meeting/_generated/deck_v5.pptx
@@ -863,7 +863,7 @@
           <a:p>
             <a:r>
               <a:rPr lang="en-US" dirty="0"/>
-              <a:t>이 슬라이드가 오늘의 핵심입니다. 인과 순서상 이미지1은 이미지2를 볼 수 없으므로 경로는 둘뿐입니다. 놀랍게도 질문이 방해 이미지를 읽는 경로만 끊으면 전면 차단과 결과가 소수점까지 같습니다. 반대로 이미지끼리 보는 경로를 끊으면 크게 나빠집니다. 즉 저희가 처음에 세웠던 '정보가 섞여서 나쁘다'는 가설은 틀렸고, 섞이는 것은 오히려 도움이 됩니다.</a:t>
+              <a:t>이 슬라이드가 오늘의 핵심입니다. 왼쪽 박스는 솔직히 말씀드리면 구조상 예상되는 결과입니다. 관련 이미지가 방해보다 앞에 있으면 방해를 볼 수 없으니, 경로가 읽기 하나로 강제됩니다. 저희 구현이 정확하다는 검증으로 봐주시면 됩니다. 진짜 발견은 오른쪽입니다. 이미지끼리 보는 경로를 끊으면 크게 나빠집니다. 방해 이미지가 관련 이미지를 보고 맥락화되면 오히려 덜 해롭고, 고립시키면 더 도드라져서 침입한다는 뜻입니다. 그리고 순서를 뒤집으면 관련 이미지가 방해를 볼 수 있게 되어 표현 오염 경로가 실제로 생깁니다. 그 배치에서 다시 재고 있습니다.</a:t>
             </a:r>
             <a:endParaRPr lang="en-US" dirty="0"/>
           </a:p>
@@ -9182,7 +9182,7 @@
                 <a:ea typeface="Arial" pitchFamily="34" charset="-122"/>
                 <a:cs typeface="Arial" pitchFamily="34" charset="-120"/>
               </a:rPr>
-              <a:t>① 읽기 경로 차단 = 전면 차단, 소수점까지 동일</a:t>
+              <a:t>① 이 배치에서는 해악의 경로가 '읽기' 하나뿐</a:t>
             </a:r>
             <a:endParaRPr lang="en-US" sz="1300" dirty="0"/>
           </a:p>
@@ -9224,7 +9224,7 @@
                 <a:ea typeface="Arial" pitchFamily="34" charset="-122"/>
                 <a:cs typeface="Arial" pitchFamily="34" charset="-120"/>
               </a:rPr>
-              <a:t>차이 0.0000, 95% CI [0, 0].</a:t>
+              <a:t>읽기 차단 = 전면 차단, 차이 0.0000 (CI [0,0]).</a:t>
             </a:r>
             <a:endParaRPr lang="en-US" sz="1100" dirty="0"/>
           </a:p>
@@ -9244,7 +9244,7 @@
                 <a:ea typeface="Arial" pitchFamily="34" charset="-122"/>
                 <a:cs typeface="Arial" pitchFamily="34" charset="-120"/>
               </a:rPr>
-              <a:t>방해 이미지의 영향은 '질문 토큰이 그것을 읽는'</a:t>
+              <a:t>관련 이미지가 방해보다 앞이라 방해를 볼 수 없기 때문 —</a:t>
             </a:r>
             <a:endParaRPr lang="en-US" sz="1100" dirty="0"/>
           </a:p>
@@ -9264,7 +9264,7 @@
                 <a:ea typeface="Arial" pitchFamily="34" charset="-122"/>
                 <a:cs typeface="Arial" pitchFamily="34" charset="-120"/>
               </a:rPr>
-              <a:t>경로 하나로만 흐릅니다. 다른 채널이 없습니다.</a:t>
+              <a:t>구조상 예상되며, 구현 정확성 검증을 겸합니다.</a:t>
             </a:r>
             <a:endParaRPr lang="en-US" sz="1100" dirty="0"/>
           </a:p>
@@ -9330,7 +9330,7 @@
                 <a:ea typeface="Arial" pitchFamily="34" charset="-122"/>
                 <a:cs typeface="Arial" pitchFamily="34" charset="-120"/>
               </a:rPr>
-              <a:t>② 이미지 간 혼합을 끊으면 오히려 크게 나빠짐</a:t>
+              <a:t>② 예상 밖 — 이미지 간 혼합을 끊으면 크게 나빠짐</a:t>
             </a:r>
             <a:endParaRPr lang="en-US" sz="1300" dirty="0"/>
           </a:p>
@@ -9392,7 +9392,7 @@
                 <a:ea typeface="Arial" pitchFamily="34" charset="-122"/>
                 <a:cs typeface="Arial" pitchFamily="34" charset="-120"/>
               </a:rPr>
-              <a:t>이미지끼리 보는 것은 도움이 됩니다.</a:t>
+              <a:t>방해가 관련 이미지를 보고 맥락화되면 오히려 덜 해롭습니다.</a:t>
             </a:r>
             <a:endParaRPr lang="en-US" sz="1100" dirty="0"/>
           </a:p>
@@ -9412,7 +9412,7 @@
                 <a:ea typeface="Arial" pitchFamily="34" charset="-122"/>
                 <a:cs typeface="Arial" pitchFamily="34" charset="-120"/>
               </a:rPr>
-              <a:t>설계 가설과 정반대 방향입니다.</a:t>
+              <a:t>고립시키면 더 도드라져 침입합니다. 이것이 실제 발견입니다.</a:t>
             </a:r>
             <a:endParaRPr lang="en-US" sz="1100" dirty="0"/>
           </a:p>
@@ -9490,7 +9490,7 @@
                 <a:ea typeface="Arial" pitchFamily="34" charset="-122"/>
                 <a:cs typeface="Arial" pitchFamily="34" charset="-120"/>
               </a:rPr>
-              <a:t>n=300 · AUC · 4D mask의 (질의 행 × 키 열) 사각형 단위 개입. 읽기차단 ≡ 전면차단은 구현 정확성 검증도 겸함</a:t>
+              <a:t>n=300 · AUC · 4D mask의 (질의 행 × 키 열) 사각형 단위 개입. 순서를 뒤집으면 관련 이미지가 방해를 볼 수 있어 표현 오염 경로가 생김 — 현재 측정 중</a:t>
             </a:r>
             <a:endParaRPr lang="en-US" sz="1000" dirty="0"/>
           </a:p>

</xml_diff>